<commit_message>
Update Trust Score overview deck: visual math slides, sources, results split
Rebuild the 11-slide deck with typeset equations (prior, matrix, fixed point
with the five sources behind the design choice, baselines) and split the
results into a metrics/ROC slide and a robustness-sweeps slide. Numbers from
the 12 Sept 2026 MGTAB run.

Co-Authored-By: Claude Fable 5.1 <noreply@anthropic.com>
</commit_message>
<xml_diff>
--- a/teams/backyard/trust-score-overview.pptx
+++ b/teams/backyard/trust-score-overview.pptx
@@ -4781,7 +4781,7 @@
           <a:p>
             <a:r>
               <a:rPr lang="en-US" dirty="0"/>
-              <a:t/>
+              <a:t>All references are in trust-score-brief.md, sections 1.4 and 4.8. Trust score = Model B of the brief (linearised BP), with Model C (a classifier) used only as the prior.</a:t>
             </a:r>
             <a:endParaRPr lang="en-US" dirty="0"/>
           </a:p>
@@ -15195,7 +15195,7 @@
                 <a:ea typeface="Cambria" pitchFamily="34" charset="-122"/>
                 <a:cs typeface="Cambria" pitchFamily="34" charset="-120"/>
               </a:rPr>
-              <a:t>Math 3: solve for the fixed point</a:t>
+              <a:t>Math 3: the trust score, and why this form</a:t>
             </a:r>
             <a:endParaRPr lang="en-US" sz="3200" dirty="0"/>
           </a:p>
@@ -15203,57 +15203,18 @@
       </p:sp>
       <p:sp>
         <p:nvSpPr>
-          <p:cNvPr id="3" name="Text 1"/>
-          <p:cNvSpPr txBox="1"/>
-          <p:nvPr/>
-        </p:nvSpPr>
-        <p:spPr>
-          <a:xfrm>
-            <a:off x="640080" y="1005840"/>
-            <a:ext cx="10972800" cy="365760"/>
-          </a:xfrm>
-          <a:prstGeom prst="rect">
-            <a:avLst/>
-          </a:prstGeom>
-          <a:noFill/>
-          <a:ln/>
-        </p:spPr>
-        <p:txBody>
-          <a:bodyPr wrap="square" lIns="0" tIns="0" rIns="0" bIns="0" rtlCol="0" anchor="ctr"/>
-          <a:lstStyle/>
-          <a:p>
-            <a:pPr indent="0" marL="0">
-              <a:buNone/>
-            </a:pPr>
-            <a:r>
-              <a:rPr lang="en-US" sz="1400" i="1" dirty="0">
-                <a:solidFill>
-                  <a:srgbClr val="C9D6DA"/>
-                </a:solidFill>
-                <a:latin typeface="Calibri" pitchFamily="34" charset="0"/>
-                <a:ea typeface="Calibri" pitchFamily="34" charset="-122"/>
-                <a:cs typeface="Calibri" pitchFamily="34" charset="-120"/>
-              </a:rPr>
-              <a:t>Each account's residual is a blend of its own prior and the average of its neighbours' residuals.</a:t>
-            </a:r>
-            <a:endParaRPr lang="en-US" sz="1400" dirty="0"/>
-          </a:p>
-        </p:txBody>
-      </p:sp>
-      <p:sp>
-        <p:nvSpPr>
-          <p:cNvPr id="4" name="Shape 2"/>
+          <p:cNvPr id="3" name="Shape 1"/>
           <p:cNvSpPr/>
           <p:nvPr/>
         </p:nvSpPr>
         <p:spPr>
           <a:xfrm>
-            <a:off x="640080" y="1554480"/>
-            <a:ext cx="5394960" cy="1371600"/>
+            <a:off x="640080" y="1143000"/>
+            <a:ext cx="10927080" cy="1783080"/>
           </a:xfrm>
           <a:prstGeom prst="roundRect">
             <a:avLst>
-              <a:gd name="adj" fmla="val 8000"/>
+              <a:gd name="adj" fmla="val 6154"/>
             </a:avLst>
           </a:prstGeom>
           <a:solidFill>
@@ -15269,7 +15230,7 @@
       </p:sp>
       <p:pic>
         <p:nvPicPr>
-          <p:cNvPr id="5" name="Image 0" descr="eq/fix.png">    </p:cNvPr>
+          <p:cNvPr id="4" name="Image 0" descr="eq/fix.png">    </p:cNvPr>
           <p:cNvPicPr>
             <a:picLocks noChangeAspect="1"/>
           </p:cNvPicPr>
@@ -15283,8 +15244,8 @@
         </p:blipFill>
         <p:spPr>
           <a:xfrm>
-            <a:off x="1005840" y="1783080"/>
-            <a:ext cx="3840480" cy="533195"/>
+            <a:off x="2194560" y="1280160"/>
+            <a:ext cx="7772400" cy="1079086"/>
           </a:xfrm>
           <a:prstGeom prst="rect">
             <a:avLst/>
@@ -15293,14 +15254,53 @@
       </p:pic>
       <p:sp>
         <p:nvSpPr>
+          <p:cNvPr id="5" name="Text 2"/>
+          <p:cNvSpPr txBox="1"/>
+          <p:nvPr/>
+        </p:nvSpPr>
+        <p:spPr>
+          <a:xfrm>
+            <a:off x="2194560" y="2450592"/>
+            <a:ext cx="3840480" cy="320040"/>
+          </a:xfrm>
+          <a:prstGeom prst="rect">
+            <a:avLst/>
+          </a:prstGeom>
+          <a:noFill/>
+          <a:ln/>
+        </p:spPr>
+        <p:txBody>
+          <a:bodyPr wrap="square" lIns="0" tIns="0" rIns="0" bIns="0" rtlCol="0" anchor="ctr"/>
+          <a:lstStyle/>
+          <a:p>
+            <a:pPr indent="0" marL="0">
+              <a:buNone/>
+            </a:pPr>
+            <a:r>
+              <a:rPr lang="en-US" sz="1200" i="1" dirty="0">
+                <a:solidFill>
+                  <a:srgbClr val="E4572E"/>
+                </a:solidFill>
+                <a:latin typeface="Calibri" pitchFamily="34" charset="0"/>
+                <a:ea typeface="Calibri" pitchFamily="34" charset="-122"/>
+                <a:cs typeface="Calibri" pitchFamily="34" charset="-120"/>
+              </a:rPr>
+              <a:t>keep (1−α) = 20% of your own prior</a:t>
+            </a:r>
+            <a:endParaRPr lang="en-US" sz="1200" dirty="0"/>
+          </a:p>
+        </p:txBody>
+      </p:sp>
+      <p:sp>
+        <p:nvSpPr>
           <p:cNvPr id="6" name="Text 3"/>
           <p:cNvSpPr txBox="1"/>
           <p:nvPr/>
         </p:nvSpPr>
         <p:spPr>
           <a:xfrm>
-            <a:off x="1005840" y="2468880"/>
-            <a:ext cx="2194560" cy="320040"/>
+            <a:off x="5852160" y="2450592"/>
+            <a:ext cx="4480560" cy="320040"/>
           </a:xfrm>
           <a:prstGeom prst="rect">
             <a:avLst/>
@@ -15312,88 +15312,49 @@
           <a:bodyPr wrap="square" lIns="0" tIns="0" rIns="0" bIns="0" rtlCol="0" anchor="ctr"/>
           <a:lstStyle/>
           <a:p>
+            <a:pPr algn="r" indent="0" marL="0">
+              <a:buNone/>
+            </a:pPr>
+            <a:r>
+              <a:rPr lang="en-US" sz="1200" i="1" dirty="0">
+                <a:solidFill>
+                  <a:srgbClr val="028090"/>
+                </a:solidFill>
+                <a:latin typeface="Calibri" pitchFamily="34" charset="0"/>
+                <a:ea typeface="Calibri" pitchFamily="34" charset="-122"/>
+                <a:cs typeface="Calibri" pitchFamily="34" charset="-120"/>
+              </a:rPr>
+              <a:t>take α = 80% from your neighbours' average</a:t>
+            </a:r>
+            <a:endParaRPr lang="en-US" sz="1200" dirty="0"/>
+          </a:p>
+        </p:txBody>
+      </p:sp>
+      <p:sp>
+        <p:nvSpPr>
+          <p:cNvPr id="7" name="Text 4"/>
+          <p:cNvSpPr txBox="1"/>
+          <p:nvPr/>
+        </p:nvSpPr>
+        <p:spPr>
+          <a:xfrm>
+            <a:off x="640080" y="3154680"/>
+            <a:ext cx="5394960" cy="365760"/>
+          </a:xfrm>
+          <a:prstGeom prst="rect">
+            <a:avLst/>
+          </a:prstGeom>
+          <a:noFill/>
+          <a:ln/>
+        </p:spPr>
+        <p:txBody>
+          <a:bodyPr wrap="square" lIns="0" tIns="0" rIns="0" bIns="0" rtlCol="0" anchor="ctr"/>
+          <a:lstStyle/>
+          <a:p>
             <a:pPr indent="0" marL="0">
               <a:buNone/>
             </a:pPr>
             <a:r>
-              <a:rPr lang="en-US" sz="1000" i="1" dirty="0">
-                <a:solidFill>
-                  <a:srgbClr val="E4572E"/>
-                </a:solidFill>
-                <a:latin typeface="Calibri" pitchFamily="34" charset="0"/>
-                <a:ea typeface="Calibri" pitchFamily="34" charset="-122"/>
-                <a:cs typeface="Calibri" pitchFamily="34" charset="-120"/>
-              </a:rPr>
-              <a:t>keep 20% of your own prior</a:t>
-            </a:r>
-            <a:endParaRPr lang="en-US" sz="1000" dirty="0"/>
-          </a:p>
-        </p:txBody>
-      </p:sp>
-      <p:sp>
-        <p:nvSpPr>
-          <p:cNvPr id="7" name="Text 4"/>
-          <p:cNvSpPr txBox="1"/>
-          <p:nvPr/>
-        </p:nvSpPr>
-        <p:spPr>
-          <a:xfrm>
-            <a:off x="3566160" y="2468880"/>
-            <a:ext cx="2286000" cy="320040"/>
-          </a:xfrm>
-          <a:prstGeom prst="rect">
-            <a:avLst/>
-          </a:prstGeom>
-          <a:noFill/>
-          <a:ln/>
-        </p:spPr>
-        <p:txBody>
-          <a:bodyPr wrap="square" lIns="0" tIns="0" rIns="0" bIns="0" rtlCol="0" anchor="ctr"/>
-          <a:lstStyle/>
-          <a:p>
-            <a:pPr indent="0" marL="0">
-              <a:buNone/>
-            </a:pPr>
-            <a:r>
-              <a:rPr lang="en-US" sz="1000" i="1" dirty="0">
-                <a:solidFill>
-                  <a:srgbClr val="028090"/>
-                </a:solidFill>
-                <a:latin typeface="Calibri" pitchFamily="34" charset="0"/>
-                <a:ea typeface="Calibri" pitchFamily="34" charset="-122"/>
-                <a:cs typeface="Calibri" pitchFamily="34" charset="-120"/>
-              </a:rPr>
-              <a:t>take 80% from neighbours</a:t>
-            </a:r>
-            <a:endParaRPr lang="en-US" sz="1000" dirty="0"/>
-          </a:p>
-        </p:txBody>
-      </p:sp>
-      <p:sp>
-        <p:nvSpPr>
-          <p:cNvPr id="8" name="Text 5"/>
-          <p:cNvSpPr txBox="1"/>
-          <p:nvPr/>
-        </p:nvSpPr>
-        <p:spPr>
-          <a:xfrm>
-            <a:off x="640080" y="3154680"/>
-            <a:ext cx="5394960" cy="548640"/>
-          </a:xfrm>
-          <a:prstGeom prst="rect">
-            <a:avLst/>
-          </a:prstGeom>
-          <a:noFill/>
-          <a:ln/>
-        </p:spPr>
-        <p:txBody>
-          <a:bodyPr wrap="square" lIns="0" tIns="0" rIns="0" bIns="0" rtlCol="0" anchor="t"/>
-          <a:lstStyle/>
-          <a:p>
-            <a:pPr indent="0" marL="0">
-              <a:buNone/>
-            </a:pPr>
-            <a:r>
               <a:rPr lang="en-US" sz="1200" dirty="0">
                 <a:solidFill>
                   <a:srgbClr val="C9D6DA"/>
@@ -15402,7 +15363,7 @@
                 <a:ea typeface="Calibri" pitchFamily="34" charset="-122"/>
                 <a:cs typeface="Calibri" pitchFamily="34" charset="-120"/>
               </a:rPr>
-              <a:t>Unrolled, the solution is a sum over hops. Each hop is discounted by α = 0.8, so distant seeds matter less.</a:t>
+              <a:t>Unrolled, the solution is a sum over hops, each discounted by α again.</a:t>
             </a:r>
             <a:endParaRPr lang="en-US" sz="1200" dirty="0"/>
           </a:p>
@@ -15410,14 +15371,14 @@
       </p:sp>
       <p:sp>
         <p:nvSpPr>
-          <p:cNvPr id="9" name="Shape 6"/>
+          <p:cNvPr id="8" name="Shape 5"/>
           <p:cNvSpPr/>
           <p:nvPr/>
         </p:nvSpPr>
         <p:spPr>
           <a:xfrm>
-            <a:off x="640080" y="3931920"/>
-            <a:ext cx="731520" cy="1005840"/>
+            <a:off x="640080" y="3611880"/>
+            <a:ext cx="731520" cy="914400"/>
           </a:xfrm>
           <a:prstGeom prst="roundRect">
             <a:avLst>
@@ -15437,7 +15398,7 @@
       </p:sp>
       <p:pic>
         <p:nvPicPr>
-          <p:cNvPr id="10" name="Image 1" descr="eq/hop0.png">    </p:cNvPr>
+          <p:cNvPr id="9" name="Image 1" descr="eq/hop0.png">    </p:cNvPr>
           <p:cNvPicPr>
             <a:picLocks noChangeAspect="1"/>
           </p:cNvPicPr>
@@ -15451,7 +15412,7 @@
         </p:blipFill>
         <p:spPr>
           <a:xfrm>
-            <a:off x="868680" y="4199486"/>
+            <a:off x="868680" y="3833726"/>
             <a:ext cx="274320" cy="470708"/>
           </a:xfrm>
           <a:prstGeom prst="rect">
@@ -15461,14 +15422,53 @@
       </p:pic>
       <p:sp>
         <p:nvSpPr>
+          <p:cNvPr id="10" name="Text 6"/>
+          <p:cNvSpPr txBox="1"/>
+          <p:nvPr/>
+        </p:nvSpPr>
+        <p:spPr>
+          <a:xfrm>
+            <a:off x="640080" y="4572000"/>
+            <a:ext cx="731520" cy="274320"/>
+          </a:xfrm>
+          <a:prstGeom prst="rect">
+            <a:avLst/>
+          </a:prstGeom>
+          <a:noFill/>
+          <a:ln/>
+        </p:spPr>
+        <p:txBody>
+          <a:bodyPr wrap="square" lIns="0" tIns="0" rIns="0" bIns="0" rtlCol="0" anchor="ctr"/>
+          <a:lstStyle/>
+          <a:p>
+            <a:pPr algn="ctr" indent="0" marL="0">
+              <a:buNone/>
+            </a:pPr>
+            <a:r>
+              <a:rPr lang="en-US" sz="1000" dirty="0">
+                <a:solidFill>
+                  <a:srgbClr val="C9D6DA"/>
+                </a:solidFill>
+                <a:latin typeface="Calibri" pitchFamily="34" charset="0"/>
+                <a:ea typeface="Calibri" pitchFamily="34" charset="-122"/>
+                <a:cs typeface="Calibri" pitchFamily="34" charset="-120"/>
+              </a:rPr>
+              <a:t>itself</a:t>
+            </a:r>
+            <a:endParaRPr lang="en-US" sz="1000" dirty="0"/>
+          </a:p>
+        </p:txBody>
+      </p:sp>
+      <p:sp>
+        <p:nvSpPr>
           <p:cNvPr id="11" name="Text 7"/>
           <p:cNvSpPr txBox="1"/>
           <p:nvPr/>
         </p:nvSpPr>
         <p:spPr>
           <a:xfrm>
-            <a:off x="640080" y="5029200"/>
-            <a:ext cx="731520" cy="274320"/>
+            <a:off x="1371600" y="3794760"/>
+            <a:ext cx="182880" cy="548640"/>
           </a:xfrm>
           <a:prstGeom prst="rect">
             <a:avLst/>
@@ -15484,7 +15484,7 @@
               <a:buNone/>
             </a:pPr>
             <a:r>
-              <a:rPr lang="en-US" sz="1000" dirty="0">
+              <a:rPr lang="en-US" sz="2200" dirty="0">
                 <a:solidFill>
                   <a:srgbClr val="C9D6DA"/>
                 </a:solidFill>
@@ -15492,45 +15492,6 @@
                 <a:ea typeface="Calibri" pitchFamily="34" charset="-122"/>
                 <a:cs typeface="Calibri" pitchFamily="34" charset="-120"/>
               </a:rPr>
-              <a:t>itself</a:t>
-            </a:r>
-            <a:endParaRPr lang="en-US" sz="1000" dirty="0"/>
-          </a:p>
-        </p:txBody>
-      </p:sp>
-      <p:sp>
-        <p:nvSpPr>
-          <p:cNvPr id="12" name="Text 8"/>
-          <p:cNvSpPr txBox="1"/>
-          <p:nvPr/>
-        </p:nvSpPr>
-        <p:spPr>
-          <a:xfrm>
-            <a:off x="1371600" y="4160520"/>
-            <a:ext cx="182880" cy="548640"/>
-          </a:xfrm>
-          <a:prstGeom prst="rect">
-            <a:avLst/>
-          </a:prstGeom>
-          <a:noFill/>
-          <a:ln/>
-        </p:spPr>
-        <p:txBody>
-          <a:bodyPr wrap="square" lIns="0" tIns="0" rIns="0" bIns="0" rtlCol="0" anchor="ctr"/>
-          <a:lstStyle/>
-          <a:p>
-            <a:pPr algn="ctr" indent="0" marL="0">
-              <a:buNone/>
-            </a:pPr>
-            <a:r>
-              <a:rPr lang="en-US" sz="2200" dirty="0">
-                <a:solidFill>
-                  <a:srgbClr val="C9D6DA"/>
-                </a:solidFill>
-                <a:latin typeface="Calibri" pitchFamily="34" charset="0"/>
-                <a:ea typeface="Calibri" pitchFamily="34" charset="-122"/>
-                <a:cs typeface="Calibri" pitchFamily="34" charset="-120"/>
-              </a:rPr>
               <a:t>+</a:t>
             </a:r>
             <a:endParaRPr lang="en-US" sz="2200" dirty="0"/>
@@ -15539,18 +15500,18 @@
       </p:sp>
       <p:sp>
         <p:nvSpPr>
-          <p:cNvPr id="13" name="Shape 9"/>
+          <p:cNvPr id="12" name="Shape 8"/>
           <p:cNvSpPr/>
           <p:nvPr/>
         </p:nvSpPr>
         <p:spPr>
           <a:xfrm>
-            <a:off x="1554480" y="3931920"/>
-            <a:ext cx="1097280" cy="1005840"/>
+            <a:off x="1554480" y="3611880"/>
+            <a:ext cx="1097280" cy="914400"/>
           </a:xfrm>
           <a:prstGeom prst="roundRect">
             <a:avLst>
-              <a:gd name="adj" fmla="val 9091"/>
+              <a:gd name="adj" fmla="val 10000"/>
             </a:avLst>
           </a:prstGeom>
           <a:solidFill>
@@ -15566,7 +15527,7 @@
       </p:sp>
       <p:pic>
         <p:nvPicPr>
-          <p:cNvPr id="14" name="Image 2" descr="eq/hop1.png">    </p:cNvPr>
+          <p:cNvPr id="13" name="Image 2" descr="eq/hop1.png">    </p:cNvPr>
           <p:cNvPicPr>
             <a:picLocks noChangeAspect="1"/>
           </p:cNvPicPr>
@@ -15580,7 +15541,7 @@
         </p:blipFill>
         <p:spPr>
           <a:xfrm>
-            <a:off x="1691640" y="4185308"/>
+            <a:off x="1691640" y="3819548"/>
             <a:ext cx="822960" cy="499064"/>
           </a:xfrm>
           <a:prstGeom prst="rect">
@@ -15590,14 +15551,53 @@
       </p:pic>
       <p:sp>
         <p:nvSpPr>
+          <p:cNvPr id="14" name="Text 9"/>
+          <p:cNvSpPr txBox="1"/>
+          <p:nvPr/>
+        </p:nvSpPr>
+        <p:spPr>
+          <a:xfrm>
+            <a:off x="1554480" y="4572000"/>
+            <a:ext cx="1097280" cy="274320"/>
+          </a:xfrm>
+          <a:prstGeom prst="rect">
+            <a:avLst/>
+          </a:prstGeom>
+          <a:noFill/>
+          <a:ln/>
+        </p:spPr>
+        <p:txBody>
+          <a:bodyPr wrap="square" lIns="0" tIns="0" rIns="0" bIns="0" rtlCol="0" anchor="ctr"/>
+          <a:lstStyle/>
+          <a:p>
+            <a:pPr algn="ctr" indent="0" marL="0">
+              <a:buNone/>
+            </a:pPr>
+            <a:r>
+              <a:rPr lang="en-US" sz="1000" dirty="0">
+                <a:solidFill>
+                  <a:srgbClr val="C9D6DA"/>
+                </a:solidFill>
+                <a:latin typeface="Calibri" pitchFamily="34" charset="0"/>
+                <a:ea typeface="Calibri" pitchFamily="34" charset="-122"/>
+                <a:cs typeface="Calibri" pitchFamily="34" charset="-120"/>
+              </a:rPr>
+              <a:t>1 hop away</a:t>
+            </a:r>
+            <a:endParaRPr lang="en-US" sz="1000" dirty="0"/>
+          </a:p>
+        </p:txBody>
+      </p:sp>
+      <p:sp>
+        <p:nvSpPr>
           <p:cNvPr id="15" name="Text 10"/>
           <p:cNvSpPr txBox="1"/>
           <p:nvPr/>
         </p:nvSpPr>
         <p:spPr>
           <a:xfrm>
-            <a:off x="1554480" y="5029200"/>
-            <a:ext cx="1097280" cy="274320"/>
+            <a:off x="2651760" y="3794760"/>
+            <a:ext cx="182880" cy="548640"/>
           </a:xfrm>
           <a:prstGeom prst="rect">
             <a:avLst/>
@@ -15613,7 +15613,7 @@
               <a:buNone/>
             </a:pPr>
             <a:r>
-              <a:rPr lang="en-US" sz="1000" dirty="0">
+              <a:rPr lang="en-US" sz="2200" dirty="0">
                 <a:solidFill>
                   <a:srgbClr val="C9D6DA"/>
                 </a:solidFill>
@@ -15621,45 +15621,6 @@
                 <a:ea typeface="Calibri" pitchFamily="34" charset="-122"/>
                 <a:cs typeface="Calibri" pitchFamily="34" charset="-120"/>
               </a:rPr>
-              <a:t>1 hop away</a:t>
-            </a:r>
-            <a:endParaRPr lang="en-US" sz="1000" dirty="0"/>
-          </a:p>
-        </p:txBody>
-      </p:sp>
-      <p:sp>
-        <p:nvSpPr>
-          <p:cNvPr id="16" name="Text 11"/>
-          <p:cNvSpPr txBox="1"/>
-          <p:nvPr/>
-        </p:nvSpPr>
-        <p:spPr>
-          <a:xfrm>
-            <a:off x="2651760" y="4160520"/>
-            <a:ext cx="182880" cy="548640"/>
-          </a:xfrm>
-          <a:prstGeom prst="rect">
-            <a:avLst/>
-          </a:prstGeom>
-          <a:noFill/>
-          <a:ln/>
-        </p:spPr>
-        <p:txBody>
-          <a:bodyPr wrap="square" lIns="0" tIns="0" rIns="0" bIns="0" rtlCol="0" anchor="ctr"/>
-          <a:lstStyle/>
-          <a:p>
-            <a:pPr algn="ctr" indent="0" marL="0">
-              <a:buNone/>
-            </a:pPr>
-            <a:r>
-              <a:rPr lang="en-US" sz="2200" dirty="0">
-                <a:solidFill>
-                  <a:srgbClr val="C9D6DA"/>
-                </a:solidFill>
-                <a:latin typeface="Calibri" pitchFamily="34" charset="0"/>
-                <a:ea typeface="Calibri" pitchFamily="34" charset="-122"/>
-                <a:cs typeface="Calibri" pitchFamily="34" charset="-120"/>
-              </a:rPr>
               <a:t>+</a:t>
             </a:r>
             <a:endParaRPr lang="en-US" sz="2200" dirty="0"/>
@@ -15668,18 +15629,18 @@
       </p:sp>
       <p:sp>
         <p:nvSpPr>
-          <p:cNvPr id="17" name="Shape 12"/>
+          <p:cNvPr id="16" name="Shape 11"/>
           <p:cNvSpPr/>
           <p:nvPr/>
         </p:nvSpPr>
         <p:spPr>
           <a:xfrm>
-            <a:off x="2834640" y="3931920"/>
-            <a:ext cx="1280160" cy="1005840"/>
+            <a:off x="2834640" y="3611880"/>
+            <a:ext cx="1280160" cy="914400"/>
           </a:xfrm>
           <a:prstGeom prst="roundRect">
             <a:avLst>
-              <a:gd name="adj" fmla="val 9091"/>
+              <a:gd name="adj" fmla="val 10000"/>
             </a:avLst>
           </a:prstGeom>
           <a:solidFill>
@@ -15695,7 +15656,7 @@
       </p:sp>
       <p:pic>
         <p:nvPicPr>
-          <p:cNvPr id="18" name="Image 3" descr="eq/hop2.png">    </p:cNvPr>
+          <p:cNvPr id="17" name="Image 3" descr="eq/hop2.png">    </p:cNvPr>
           <p:cNvPicPr>
             <a:picLocks noChangeAspect="1"/>
           </p:cNvPicPr>
@@ -15709,7 +15670,7 @@
         </p:blipFill>
         <p:spPr>
           <a:xfrm>
-            <a:off x="2971800" y="4215653"/>
+            <a:off x="2971800" y="3849893"/>
             <a:ext cx="1005840" cy="438374"/>
           </a:xfrm>
           <a:prstGeom prst="rect">
@@ -15719,14 +15680,53 @@
       </p:pic>
       <p:sp>
         <p:nvSpPr>
+          <p:cNvPr id="18" name="Text 12"/>
+          <p:cNvSpPr txBox="1"/>
+          <p:nvPr/>
+        </p:nvSpPr>
+        <p:spPr>
+          <a:xfrm>
+            <a:off x="2834640" y="4572000"/>
+            <a:ext cx="1280160" cy="274320"/>
+          </a:xfrm>
+          <a:prstGeom prst="rect">
+            <a:avLst/>
+          </a:prstGeom>
+          <a:noFill/>
+          <a:ln/>
+        </p:spPr>
+        <p:txBody>
+          <a:bodyPr wrap="square" lIns="0" tIns="0" rIns="0" bIns="0" rtlCol="0" anchor="ctr"/>
+          <a:lstStyle/>
+          <a:p>
+            <a:pPr algn="ctr" indent="0" marL="0">
+              <a:buNone/>
+            </a:pPr>
+            <a:r>
+              <a:rPr lang="en-US" sz="1000" dirty="0">
+                <a:solidFill>
+                  <a:srgbClr val="C9D6DA"/>
+                </a:solidFill>
+                <a:latin typeface="Calibri" pitchFamily="34" charset="0"/>
+                <a:ea typeface="Calibri" pitchFamily="34" charset="-122"/>
+                <a:cs typeface="Calibri" pitchFamily="34" charset="-120"/>
+              </a:rPr>
+              <a:t>2 hops away</a:t>
+            </a:r>
+            <a:endParaRPr lang="en-US" sz="1000" dirty="0"/>
+          </a:p>
+        </p:txBody>
+      </p:sp>
+      <p:sp>
+        <p:nvSpPr>
           <p:cNvPr id="19" name="Text 13"/>
           <p:cNvSpPr txBox="1"/>
           <p:nvPr/>
         </p:nvSpPr>
         <p:spPr>
           <a:xfrm>
-            <a:off x="2834640" y="5029200"/>
-            <a:ext cx="1280160" cy="274320"/>
+            <a:off x="4114800" y="3794760"/>
+            <a:ext cx="182880" cy="548640"/>
           </a:xfrm>
           <a:prstGeom prst="rect">
             <a:avLst/>
@@ -15742,7 +15742,7 @@
               <a:buNone/>
             </a:pPr>
             <a:r>
-              <a:rPr lang="en-US" sz="1000" dirty="0">
+              <a:rPr lang="en-US" sz="2200" dirty="0">
                 <a:solidFill>
                   <a:srgbClr val="C9D6DA"/>
                 </a:solidFill>
@@ -15750,45 +15750,6 @@
                 <a:ea typeface="Calibri" pitchFamily="34" charset="-122"/>
                 <a:cs typeface="Calibri" pitchFamily="34" charset="-120"/>
               </a:rPr>
-              <a:t>2 hops away</a:t>
-            </a:r>
-            <a:endParaRPr lang="en-US" sz="1000" dirty="0"/>
-          </a:p>
-        </p:txBody>
-      </p:sp>
-      <p:sp>
-        <p:nvSpPr>
-          <p:cNvPr id="20" name="Text 14"/>
-          <p:cNvSpPr txBox="1"/>
-          <p:nvPr/>
-        </p:nvSpPr>
-        <p:spPr>
-          <a:xfrm>
-            <a:off x="4114800" y="4160520"/>
-            <a:ext cx="182880" cy="548640"/>
-          </a:xfrm>
-          <a:prstGeom prst="rect">
-            <a:avLst/>
-          </a:prstGeom>
-          <a:noFill/>
-          <a:ln/>
-        </p:spPr>
-        <p:txBody>
-          <a:bodyPr wrap="square" lIns="0" tIns="0" rIns="0" bIns="0" rtlCol="0" anchor="ctr"/>
-          <a:lstStyle/>
-          <a:p>
-            <a:pPr algn="ctr" indent="0" marL="0">
-              <a:buNone/>
-            </a:pPr>
-            <a:r>
-              <a:rPr lang="en-US" sz="2200" dirty="0">
-                <a:solidFill>
-                  <a:srgbClr val="C9D6DA"/>
-                </a:solidFill>
-                <a:latin typeface="Calibri" pitchFamily="34" charset="0"/>
-                <a:ea typeface="Calibri" pitchFamily="34" charset="-122"/>
-                <a:cs typeface="Calibri" pitchFamily="34" charset="-120"/>
-              </a:rPr>
               <a:t>+</a:t>
             </a:r>
             <a:endParaRPr lang="en-US" sz="2200" dirty="0"/>
@@ -15797,18 +15758,18 @@
       </p:sp>
       <p:sp>
         <p:nvSpPr>
-          <p:cNvPr id="21" name="Shape 15"/>
+          <p:cNvPr id="20" name="Shape 14"/>
           <p:cNvSpPr/>
           <p:nvPr/>
         </p:nvSpPr>
         <p:spPr>
           <a:xfrm>
-            <a:off x="4297680" y="3931920"/>
-            <a:ext cx="1371600" cy="1005840"/>
+            <a:off x="4297680" y="3611880"/>
+            <a:ext cx="1371600" cy="914400"/>
           </a:xfrm>
           <a:prstGeom prst="roundRect">
             <a:avLst>
-              <a:gd name="adj" fmla="val 9091"/>
+              <a:gd name="adj" fmla="val 10000"/>
             </a:avLst>
           </a:prstGeom>
           <a:solidFill>
@@ -15824,7 +15785,7 @@
       </p:sp>
       <p:pic>
         <p:nvPicPr>
-          <p:cNvPr id="22" name="Image 4" descr="eq/hop3.png">    </p:cNvPr>
+          <p:cNvPr id="21" name="Image 4" descr="eq/hop3.png">    </p:cNvPr>
           <p:cNvPicPr>
             <a:picLocks noChangeAspect="1"/>
           </p:cNvPicPr>
@@ -15838,7 +15799,7 @@
         </p:blipFill>
         <p:spPr>
           <a:xfrm>
-            <a:off x="4434840" y="4260175"/>
+            <a:off x="4434840" y="3894415"/>
             <a:ext cx="1097280" cy="349329"/>
           </a:xfrm>
           <a:prstGeom prst="rect">
@@ -15848,13 +15809,13 @@
       </p:pic>
       <p:sp>
         <p:nvSpPr>
-          <p:cNvPr id="23" name="Text 16"/>
-          <p:cNvSpPr txBox="1"/>
-          <p:nvPr/>
-        </p:nvSpPr>
-        <p:spPr>
-          <a:xfrm>
-            <a:off x="4297680" y="5029200"/>
+          <p:cNvPr id="22" name="Text 15"/>
+          <p:cNvSpPr txBox="1"/>
+          <p:nvPr/>
+        </p:nvSpPr>
+        <p:spPr>
+          <a:xfrm>
+            <a:off x="4297680" y="4572000"/>
             <a:ext cx="1371600" cy="274320"/>
           </a:xfrm>
           <a:prstGeom prst="rect">
@@ -15884,115 +15845,10 @@
             <a:endParaRPr lang="en-US" sz="1000" dirty="0"/>
           </a:p>
         </p:txBody>
-      </p:sp>
-      <p:sp>
-        <p:nvSpPr>
-          <p:cNvPr id="24" name="Text 17"/>
-          <p:cNvSpPr txBox="1"/>
-          <p:nvPr/>
-        </p:nvSpPr>
-        <p:spPr>
-          <a:xfrm>
-            <a:off x="640080" y="5303520"/>
-            <a:ext cx="914400" cy="274320"/>
-          </a:xfrm>
-          <a:prstGeom prst="rect">
-            <a:avLst/>
-          </a:prstGeom>
-          <a:noFill/>
-          <a:ln/>
-        </p:spPr>
-        <p:txBody>
-          <a:bodyPr wrap="square" lIns="0" tIns="0" rIns="0" bIns="0" rtlCol="0" anchor="ctr"/>
-          <a:lstStyle/>
-          <a:p>
-            <a:pPr algn="ctr" indent="0" marL="0">
-              <a:buNone/>
-            </a:pPr>
-            <a:r>
-              <a:rPr lang="en-US" sz="900" i="1" dirty="0">
-                <a:solidFill>
-                  <a:srgbClr val="02C39A"/>
-                </a:solidFill>
-                <a:latin typeface="Calibri" pitchFamily="34" charset="0"/>
-                <a:ea typeface="Calibri" pitchFamily="34" charset="-122"/>
-                <a:cs typeface="Calibri" pitchFamily="34" charset="-120"/>
-              </a:rPr>
-              <a:t>weight 1.0</a:t>
-            </a:r>
-            <a:endParaRPr lang="en-US" sz="900" dirty="0"/>
-          </a:p>
-        </p:txBody>
-      </p:sp>
-      <p:sp>
-        <p:nvSpPr>
-          <p:cNvPr id="25" name="Text 18"/>
-          <p:cNvSpPr txBox="1"/>
-          <p:nvPr/>
-        </p:nvSpPr>
-        <p:spPr>
-          <a:xfrm>
-            <a:off x="640080" y="5669280"/>
-            <a:ext cx="5394960" cy="548640"/>
-          </a:xfrm>
-          <a:prstGeom prst="rect">
-            <a:avLst/>
-          </a:prstGeom>
-          <a:noFill/>
-          <a:ln/>
-        </p:spPr>
-        <p:txBody>
-          <a:bodyPr wrap="square" lIns="0" tIns="0" rIns="0" bIns="0" rtlCol="0" anchor="t"/>
-          <a:lstStyle/>
-          <a:p>
-            <a:pPr indent="0" marL="0">
-              <a:buNone/>
-            </a:pPr>
-            <a:r>
-              <a:rPr lang="en-US" sz="1100" i="1" dirty="0">
-                <a:solidFill>
-                  <a:srgbClr val="C9D6DA"/>
-                </a:solidFill>
-                <a:latin typeface="Calibri" pitchFamily="34" charset="0"/>
-                <a:ea typeface="Calibri" pitchFamily="34" charset="-122"/>
-                <a:cs typeface="Calibri" pitchFamily="34" charset="-120"/>
-              </a:rPr>
-              <a:t>Each further hop is multiplied by α = 0.8 again: 0.8, 0.64, 0.51, … Seeds far away still count, but less.</a:t>
-            </a:r>
-            <a:endParaRPr lang="en-US" sz="1100" dirty="0"/>
-          </a:p>
-        </p:txBody>
-      </p:sp>
-      <p:sp>
-        <p:nvSpPr>
-          <p:cNvPr id="26" name="Shape 19"/>
-          <p:cNvSpPr/>
-          <p:nvPr/>
-        </p:nvSpPr>
-        <p:spPr>
-          <a:xfrm>
-            <a:off x="6400800" y="1554480"/>
-            <a:ext cx="5303520" cy="1143000"/>
-          </a:xfrm>
-          <a:prstGeom prst="roundRect">
-            <a:avLst>
-              <a:gd name="adj" fmla="val 9600"/>
-            </a:avLst>
-          </a:prstGeom>
-          <a:solidFill>
-            <a:srgbClr val="FFFFFF"/>
-          </a:solidFill>
-          <a:ln w="12700">
-            <a:solidFill>
-              <a:srgbClr val="FFFFFF"/>
-            </a:solidFill>
-            <a:prstDash val="solid"/>
-          </a:ln>
-        </p:spPr>
       </p:sp>
       <p:pic>
         <p:nvPicPr>
-          <p:cNvPr id="27" name="Image 5" descr="eq/sol.png">    </p:cNvPr>
+          <p:cNvPr id="23" name="Image 5" descr="eq/sol_w.png">    </p:cNvPr>
           <p:cNvPicPr>
             <a:picLocks noChangeAspect="1"/>
           </p:cNvPicPr>
@@ -16006,44 +15862,17 @@
         </p:blipFill>
         <p:spPr>
           <a:xfrm>
-            <a:off x="6583680" y="1810512"/>
-            <a:ext cx="4937760" cy="635839"/>
+            <a:off x="640080" y="5029200"/>
+            <a:ext cx="5394960" cy="694713"/>
           </a:xfrm>
           <a:prstGeom prst="rect">
             <a:avLst/>
           </a:prstGeom>
         </p:spPr>
       </p:pic>
-      <p:sp>
-        <p:nvSpPr>
-          <p:cNvPr id="28" name="Shape 20"/>
-          <p:cNvSpPr/>
-          <p:nvPr/>
-        </p:nvSpPr>
-        <p:spPr>
-          <a:xfrm>
-            <a:off x="6400800" y="2880360"/>
-            <a:ext cx="5303520" cy="914400"/>
-          </a:xfrm>
-          <a:prstGeom prst="roundRect">
-            <a:avLst>
-              <a:gd name="adj" fmla="val 12000"/>
-            </a:avLst>
-          </a:prstGeom>
-          <a:solidFill>
-            <a:srgbClr val="FFFFFF"/>
-          </a:solidFill>
-          <a:ln w="12700">
-            <a:solidFill>
-              <a:srgbClr val="FFFFFF"/>
-            </a:solidFill>
-            <a:prstDash val="solid"/>
-          </a:ln>
-        </p:spPr>
-      </p:sp>
       <p:pic>
         <p:nvPicPr>
-          <p:cNvPr id="29" name="Image 6" descr="eq/trust.png">    </p:cNvPr>
+          <p:cNvPr id="24" name="Image 6" descr="eq/trust_w.png">    </p:cNvPr>
           <p:cNvPicPr>
             <a:picLocks noChangeAspect="1"/>
           </p:cNvPicPr>
@@ -16057,8 +15886,8 @@
         </p:blipFill>
         <p:spPr>
           <a:xfrm>
-            <a:off x="6583680" y="3154680"/>
-            <a:ext cx="4937760" cy="351075"/>
+            <a:off x="640080" y="5806440"/>
+            <a:ext cx="5394960" cy="383581"/>
           </a:xfrm>
           <a:prstGeom prst="rect">
             <a:avLst/>
@@ -16067,14 +15896,53 @@
       </p:pic>
       <p:sp>
         <p:nvSpPr>
-          <p:cNvPr id="30" name="Shape 21"/>
+          <p:cNvPr id="25" name="Text 16"/>
+          <p:cNvSpPr txBox="1"/>
+          <p:nvPr/>
+        </p:nvSpPr>
+        <p:spPr>
+          <a:xfrm>
+            <a:off x="6400800" y="3154680"/>
+            <a:ext cx="5303520" cy="365760"/>
+          </a:xfrm>
+          <a:prstGeom prst="rect">
+            <a:avLst/>
+          </a:prstGeom>
+          <a:noFill/>
+          <a:ln/>
+        </p:spPr>
+        <p:txBody>
+          <a:bodyPr wrap="square" lIns="0" tIns="0" rIns="0" bIns="0" rtlCol="0" anchor="ctr"/>
+          <a:lstStyle/>
+          <a:p>
+            <a:pPr indent="0" marL="0">
+              <a:buNone/>
+            </a:pPr>
+            <a:r>
+              <a:rPr lang="en-US" sz="1400" b="1" dirty="0">
+                <a:solidFill>
+                  <a:srgbClr val="FFFFFF"/>
+                </a:solidFill>
+                <a:latin typeface="Calibri" pitchFamily="34" charset="0"/>
+                <a:ea typeface="Calibri" pitchFamily="34" charset="-122"/>
+                <a:cs typeface="Calibri" pitchFamily="34" charset="-120"/>
+              </a:rPr>
+              <a:t>Why this form: the sources behind the choice</a:t>
+            </a:r>
+            <a:endParaRPr lang="en-US" sz="1400" dirty="0"/>
+          </a:p>
+        </p:txBody>
+      </p:sp>
+      <p:sp>
+        <p:nvSpPr>
+          <p:cNvPr id="26" name="Shape 17"/>
           <p:cNvSpPr/>
           <p:nvPr/>
         </p:nvSpPr>
         <p:spPr>
           <a:xfrm>
-            <a:off x="6400800" y="4069080"/>
-            <a:ext cx="329184" cy="329184"/>
+            <a:off x="6400800" y="3584448"/>
+            <a:ext cx="256032" cy="256032"/>
           </a:xfrm>
           <a:prstGeom prst="ellipse">
             <a:avLst/>
@@ -16092,14 +15960,14 @@
       </p:sp>
       <p:sp>
         <p:nvSpPr>
-          <p:cNvPr id="31" name="Text 22"/>
-          <p:cNvSpPr txBox="1"/>
-          <p:nvPr/>
-        </p:nvSpPr>
-        <p:spPr>
-          <a:xfrm>
-            <a:off x="6400800" y="4069080"/>
-            <a:ext cx="329184" cy="329184"/>
+          <p:cNvPr id="27" name="Text 18"/>
+          <p:cNvSpPr txBox="1"/>
+          <p:nvPr/>
+        </p:nvSpPr>
+        <p:spPr>
+          <a:xfrm>
+            <a:off x="6400800" y="3584448"/>
+            <a:ext cx="256032" cy="256032"/>
           </a:xfrm>
           <a:prstGeom prst="rect">
             <a:avLst/>
@@ -16123,7 +15991,7 @@
                 <a:ea typeface="Calibri" pitchFamily="34" charset="-122"/>
                 <a:cs typeface="Calibri" pitchFamily="34" charset="-120"/>
               </a:rPr>
-              <a:t>✓</a:t>
+              <a:t>1</a:t>
             </a:r>
             <a:endParaRPr lang="en-US" sz="1600" dirty="0"/>
           </a:p>
@@ -16131,30 +15999,30 @@
       </p:sp>
       <p:sp>
         <p:nvSpPr>
-          <p:cNvPr id="32" name="Text 23"/>
-          <p:cNvSpPr txBox="1"/>
-          <p:nvPr/>
-        </p:nvSpPr>
-        <p:spPr>
-          <a:xfrm>
-            <a:off x="6858000" y="4050792"/>
-            <a:ext cx="4846320" cy="292608"/>
-          </a:xfrm>
-          <a:prstGeom prst="rect">
-            <a:avLst/>
-          </a:prstGeom>
-          <a:noFill/>
-          <a:ln/>
-        </p:spPr>
-        <p:txBody>
-          <a:bodyPr wrap="square" lIns="0" tIns="0" rIns="0" bIns="0" rtlCol="0" anchor="ctr"/>
+          <p:cNvPr id="28" name="Text 19"/>
+          <p:cNvSpPr txBox="1"/>
+          <p:nvPr/>
+        </p:nvSpPr>
+        <p:spPr>
+          <a:xfrm>
+            <a:off x="6766560" y="3566160"/>
+            <a:ext cx="4937760" cy="566928"/>
+          </a:xfrm>
+          <a:prstGeom prst="rect">
+            <a:avLst/>
+          </a:prstGeom>
+          <a:noFill/>
+          <a:ln/>
+        </p:spPr>
+        <p:txBody>
+          <a:bodyPr wrap="square" lIns="0" tIns="0" rIns="0" bIns="0" rtlCol="0" anchor="t"/>
           <a:lstStyle/>
           <a:p>
             <a:pPr indent="0" marL="0">
               <a:buNone/>
             </a:pPr>
             <a:r>
-              <a:rPr lang="en-US" sz="1200" b="1" dirty="0">
+              <a:rPr lang="en-US" sz="900" b="1" dirty="0">
                 <a:solidFill>
                   <a:srgbClr val="FFFFFF"/>
                 </a:solidFill>
@@ -16162,38 +16030,16 @@
                 <a:ea typeface="Calibri" pitchFamily="34" charset="-122"/>
                 <a:cs typeface="Calibri" pitchFamily="34" charset="-120"/>
               </a:rPr>
-              <a:t>Unique</a:t>
-            </a:r>
-            <a:endParaRPr lang="en-US" sz="1200" dirty="0"/>
-          </a:p>
-        </p:txBody>
-      </p:sp>
-      <p:sp>
-        <p:nvSpPr>
-          <p:cNvPr id="33" name="Text 24"/>
-          <p:cNvSpPr txBox="1"/>
-          <p:nvPr/>
-        </p:nvSpPr>
-        <p:spPr>
-          <a:xfrm>
-            <a:off x="6858000" y="4343400"/>
-            <a:ext cx="4846320" cy="502920"/>
-          </a:xfrm>
-          <a:prstGeom prst="rect">
-            <a:avLst/>
-          </a:prstGeom>
-          <a:noFill/>
-          <a:ln/>
-        </p:spPr>
-        <p:txBody>
-          <a:bodyPr wrap="square" lIns="0" tIns="0" rIns="0" bIns="0" rtlCol="0" anchor="t"/>
-          <a:lstStyle/>
+              <a:t>SybilSCAR, Wang et al., INFOCOM 2017</a:t>
+            </a:r>
+            <a:endParaRPr lang="en-US" sz="900" dirty="0"/>
+          </a:p>
           <a:p>
             <a:pPr indent="0" marL="0">
               <a:buNone/>
             </a:pPr>
             <a:r>
-              <a:rPr lang="en-US" sz="1000" dirty="0">
+              <a:rPr lang="en-US" sz="900" dirty="0">
                 <a:solidFill>
                   <a:srgbClr val="C9D6DA"/>
                 </a:solidFill>
@@ -16201,22 +16047,22 @@
                 <a:ea typeface="Calibri" pitchFamily="34" charset="-122"/>
                 <a:cs typeface="Calibri" pitchFamily="34" charset="-120"/>
               </a:rPr>
-              <a:t>P is row-stochastic, so the map is a contraction with rate α. One answer, reached in 54 iterations.</a:t>
-            </a:r>
-            <a:endParaRPr lang="en-US" sz="1000" dirty="0"/>
-          </a:p>
-        </p:txBody>
-      </p:sp>
-      <p:sp>
-        <p:nvSpPr>
-          <p:cNvPr id="34" name="Shape 25"/>
+              <a:t>Linearised belief propagation with both trust and distrust seeds. Converges when the spectral radius is below 1, one sparse pass per iteration. Our core.</a:t>
+            </a:r>
+            <a:endParaRPr lang="en-US" sz="900" dirty="0"/>
+          </a:p>
+        </p:txBody>
+      </p:sp>
+      <p:sp>
+        <p:nvSpPr>
+          <p:cNvPr id="29" name="Shape 20"/>
           <p:cNvSpPr/>
           <p:nvPr/>
         </p:nvSpPr>
         <p:spPr>
           <a:xfrm>
-            <a:off x="6400800" y="4846320"/>
-            <a:ext cx="329184" cy="329184"/>
+            <a:off x="6400800" y="4169664"/>
+            <a:ext cx="256032" cy="256032"/>
           </a:xfrm>
           <a:prstGeom prst="ellipse">
             <a:avLst/>
@@ -16234,14 +16080,14 @@
       </p:sp>
       <p:sp>
         <p:nvSpPr>
-          <p:cNvPr id="35" name="Text 26"/>
-          <p:cNvSpPr txBox="1"/>
-          <p:nvPr/>
-        </p:nvSpPr>
-        <p:spPr>
-          <a:xfrm>
-            <a:off x="6400800" y="4846320"/>
-            <a:ext cx="329184" cy="329184"/>
+          <p:cNvPr id="30" name="Text 21"/>
+          <p:cNvSpPr txBox="1"/>
+          <p:nvPr/>
+        </p:nvSpPr>
+        <p:spPr>
+          <a:xfrm>
+            <a:off x="6400800" y="4169664"/>
+            <a:ext cx="256032" cy="256032"/>
           </a:xfrm>
           <a:prstGeom prst="rect">
             <a:avLst/>
@@ -16265,7 +16111,7 @@
                 <a:ea typeface="Calibri" pitchFamily="34" charset="-122"/>
                 <a:cs typeface="Calibri" pitchFamily="34" charset="-120"/>
               </a:rPr>
-              <a:t>✓</a:t>
+              <a:t>2</a:t>
             </a:r>
             <a:endParaRPr lang="en-US" sz="1600" dirty="0"/>
           </a:p>
@@ -16273,30 +16119,30 @@
       </p:sp>
       <p:sp>
         <p:nvSpPr>
-          <p:cNvPr id="36" name="Text 27"/>
-          <p:cNvSpPr txBox="1"/>
-          <p:nvPr/>
-        </p:nvSpPr>
-        <p:spPr>
-          <a:xfrm>
-            <a:off x="6858000" y="4828032"/>
-            <a:ext cx="4846320" cy="292608"/>
-          </a:xfrm>
-          <a:prstGeom prst="rect">
-            <a:avLst/>
-          </a:prstGeom>
-          <a:noFill/>
-          <a:ln/>
-        </p:spPr>
-        <p:txBody>
-          <a:bodyPr wrap="square" lIns="0" tIns="0" rIns="0" bIns="0" rtlCol="0" anchor="ctr"/>
+          <p:cNvPr id="31" name="Text 22"/>
+          <p:cNvSpPr txBox="1"/>
+          <p:nvPr/>
+        </p:nvSpPr>
+        <p:spPr>
+          <a:xfrm>
+            <a:off x="6766560" y="4151376"/>
+            <a:ext cx="4937760" cy="566928"/>
+          </a:xfrm>
+          <a:prstGeom prst="rect">
+            <a:avLst/>
+          </a:prstGeom>
+          <a:noFill/>
+          <a:ln/>
+        </p:spPr>
+        <p:txBody>
+          <a:bodyPr wrap="square" lIns="0" tIns="0" rIns="0" bIns="0" rtlCol="0" anchor="t"/>
           <a:lstStyle/>
           <a:p>
             <a:pPr indent="0" marL="0">
               <a:buNone/>
             </a:pPr>
             <a:r>
-              <a:rPr lang="en-US" sz="1200" b="1" dirty="0">
+              <a:rPr lang="en-US" sz="900" b="1" dirty="0">
                 <a:solidFill>
                   <a:srgbClr val="FFFFFF"/>
                 </a:solidFill>
@@ -16304,38 +16150,16 @@
                 <a:ea typeface="Calibri" pitchFamily="34" charset="-122"/>
                 <a:cs typeface="Calibri" pitchFamily="34" charset="-120"/>
               </a:rPr>
-              <a:t>Bounded</a:t>
-            </a:r>
-            <a:endParaRPr lang="en-US" sz="1200" dirty="0"/>
-          </a:p>
-        </p:txBody>
-      </p:sp>
-      <p:sp>
-        <p:nvSpPr>
-          <p:cNvPr id="37" name="Text 28"/>
-          <p:cNvSpPr txBox="1"/>
-          <p:nvPr/>
-        </p:nvSpPr>
-        <p:spPr>
-          <a:xfrm>
-            <a:off x="6858000" y="5120640"/>
-            <a:ext cx="4846320" cy="502920"/>
-          </a:xfrm>
-          <a:prstGeom prst="rect">
-            <a:avLst/>
-          </a:prstGeom>
-          <a:noFill/>
-          <a:ln/>
-        </p:spPr>
-        <p:txBody>
-          <a:bodyPr wrap="square" lIns="0" tIns="0" rIns="0" bIns="0" rtlCol="0" anchor="t"/>
-          <a:lstStyle/>
+              <a:t>GANG, Wang et al., ICDM 2017</a:t>
+            </a:r>
+            <a:endParaRPr lang="en-US" sz="900" dirty="0"/>
+          </a:p>
           <a:p>
             <a:pPr indent="0" marL="0">
               <a:buNone/>
             </a:pPr>
             <a:r>
-              <a:rPr lang="en-US" sz="1000" dirty="0">
+              <a:rPr lang="en-US" sz="900" dirty="0">
                 <a:solidFill>
                   <a:srgbClr val="C9D6DA"/>
                 </a:solidFill>
@@ -16343,22 +16167,22 @@
                 <a:ea typeface="Calibri" pitchFamily="34" charset="-122"/>
                 <a:cs typeface="Calibri" pitchFamily="34" charset="-120"/>
               </a:rPr>
-              <a:t>|q| ≤ ½ implies |r*| ≤ ½, so trust always lands in [0, 1] without clipping.</a:t>
-            </a:r>
-            <a:endParaRPr lang="en-US" sz="1000" dirty="0"/>
-          </a:p>
-        </p:txBody>
-      </p:sp>
-      <p:sp>
-        <p:nvSpPr>
-          <p:cNvPr id="38" name="Shape 29"/>
+              <a:t>Same idea on directed graphs: evidence flows differently along each edge direction. Our follow_in / follow_out channels.</a:t>
+            </a:r>
+            <a:endParaRPr lang="en-US" sz="900" dirty="0"/>
+          </a:p>
+        </p:txBody>
+      </p:sp>
+      <p:sp>
+        <p:nvSpPr>
+          <p:cNvPr id="32" name="Shape 23"/>
           <p:cNvSpPr/>
           <p:nvPr/>
         </p:nvSpPr>
         <p:spPr>
           <a:xfrm>
-            <a:off x="6400800" y="5623560"/>
-            <a:ext cx="329184" cy="329184"/>
+            <a:off x="6400800" y="4754880"/>
+            <a:ext cx="256032" cy="256032"/>
           </a:xfrm>
           <a:prstGeom prst="ellipse">
             <a:avLst/>
@@ -16376,14 +16200,254 @@
       </p:sp>
       <p:sp>
         <p:nvSpPr>
+          <p:cNvPr id="33" name="Text 24"/>
+          <p:cNvSpPr txBox="1"/>
+          <p:nvPr/>
+        </p:nvSpPr>
+        <p:spPr>
+          <a:xfrm>
+            <a:off x="6400800" y="4754880"/>
+            <a:ext cx="256032" cy="256032"/>
+          </a:xfrm>
+          <a:prstGeom prst="rect">
+            <a:avLst/>
+          </a:prstGeom>
+          <a:noFill/>
+          <a:ln/>
+        </p:spPr>
+        <p:txBody>
+          <a:bodyPr wrap="square" lIns="0" tIns="0" rIns="0" bIns="0" rtlCol="0" anchor="ctr"/>
+          <a:lstStyle/>
+          <a:p>
+            <a:pPr algn="ctr" indent="0" marL="0">
+              <a:buNone/>
+            </a:pPr>
+            <a:r>
+              <a:rPr lang="en-US" sz="1600" b="1" dirty="0">
+                <a:solidFill>
+                  <a:srgbClr val="FFFFFF"/>
+                </a:solidFill>
+                <a:latin typeface="Calibri" pitchFamily="34" charset="0"/>
+                <a:ea typeface="Calibri" pitchFamily="34" charset="-122"/>
+                <a:cs typeface="Calibri" pitchFamily="34" charset="-120"/>
+              </a:rPr>
+              <a:t>3</a:t>
+            </a:r>
+            <a:endParaRPr lang="en-US" sz="1600" dirty="0"/>
+          </a:p>
+        </p:txBody>
+      </p:sp>
+      <p:sp>
+        <p:nvSpPr>
+          <p:cNvPr id="34" name="Text 25"/>
+          <p:cNvSpPr txBox="1"/>
+          <p:nvPr/>
+        </p:nvSpPr>
+        <p:spPr>
+          <a:xfrm>
+            <a:off x="6766560" y="4736592"/>
+            <a:ext cx="4937760" cy="566928"/>
+          </a:xfrm>
+          <a:prstGeom prst="rect">
+            <a:avLst/>
+          </a:prstGeom>
+          <a:noFill/>
+          <a:ln/>
+        </p:spPr>
+        <p:txBody>
+          <a:bodyPr wrap="square" lIns="0" tIns="0" rIns="0" bIns="0" rtlCol="0" anchor="t"/>
+          <a:lstStyle/>
+          <a:p>
+            <a:pPr indent="0" marL="0">
+              <a:buNone/>
+            </a:pPr>
+            <a:r>
+              <a:rPr lang="en-US" sz="900" b="1" dirty="0">
+                <a:solidFill>
+                  <a:srgbClr val="FFFFFF"/>
+                </a:solidFill>
+                <a:latin typeface="Calibri" pitchFamily="34" charset="0"/>
+                <a:ea typeface="Calibri" pitchFamily="34" charset="-122"/>
+                <a:cs typeface="Calibri" pitchFamily="34" charset="-120"/>
+              </a:rPr>
+              <a:t>SybilRank, NSDI 2012 · TrustRank, VLDB 2004</a:t>
+            </a:r>
+            <a:endParaRPr lang="en-US" sz="900" dirty="0"/>
+          </a:p>
+          <a:p>
+            <a:pPr indent="0" marL="0">
+              <a:buNone/>
+            </a:pPr>
+            <a:r>
+              <a:rPr lang="en-US" sz="900" dirty="0">
+                <a:solidFill>
+                  <a:srgbClr val="C9D6DA"/>
+                </a:solidFill>
+                <a:latin typeface="Calibri" pitchFamily="34" charset="0"/>
+                <a:ea typeface="Calibri" pitchFamily="34" charset="-122"/>
+                <a:cs typeface="Calibri" pitchFamily="34" charset="-120"/>
+              </a:rPr>
+              <a:t>Seeded random walks with a provable bound of O(g·log n) misplaced Sybils. Our α-damped form is this family; α is the restart.</a:t>
+            </a:r>
+            <a:endParaRPr lang="en-US" sz="900" dirty="0"/>
+          </a:p>
+        </p:txBody>
+      </p:sp>
+      <p:sp>
+        <p:nvSpPr>
+          <p:cNvPr id="35" name="Shape 26"/>
+          <p:cNvSpPr/>
+          <p:nvPr/>
+        </p:nvSpPr>
+        <p:spPr>
+          <a:xfrm>
+            <a:off x="6400800" y="5340096"/>
+            <a:ext cx="256032" cy="256032"/>
+          </a:xfrm>
+          <a:prstGeom prst="ellipse">
+            <a:avLst/>
+          </a:prstGeom>
+          <a:solidFill>
+            <a:srgbClr val="02C39A"/>
+          </a:solidFill>
+          <a:ln w="12700">
+            <a:solidFill>
+              <a:srgbClr val="02C39A"/>
+            </a:solidFill>
+            <a:prstDash val="solid"/>
+          </a:ln>
+        </p:spPr>
+      </p:sp>
+      <p:sp>
+        <p:nvSpPr>
+          <p:cNvPr id="36" name="Text 27"/>
+          <p:cNvSpPr txBox="1"/>
+          <p:nvPr/>
+        </p:nvSpPr>
+        <p:spPr>
+          <a:xfrm>
+            <a:off x="6400800" y="5340096"/>
+            <a:ext cx="256032" cy="256032"/>
+          </a:xfrm>
+          <a:prstGeom prst="rect">
+            <a:avLst/>
+          </a:prstGeom>
+          <a:noFill/>
+          <a:ln/>
+        </p:spPr>
+        <p:txBody>
+          <a:bodyPr wrap="square" lIns="0" tIns="0" rIns="0" bIns="0" rtlCol="0" anchor="ctr"/>
+          <a:lstStyle/>
+          <a:p>
+            <a:pPr algn="ctr" indent="0" marL="0">
+              <a:buNone/>
+            </a:pPr>
+            <a:r>
+              <a:rPr lang="en-US" sz="1600" b="1" dirty="0">
+                <a:solidFill>
+                  <a:srgbClr val="FFFFFF"/>
+                </a:solidFill>
+                <a:latin typeface="Calibri" pitchFamily="34" charset="0"/>
+                <a:ea typeface="Calibri" pitchFamily="34" charset="-122"/>
+                <a:cs typeface="Calibri" pitchFamily="34" charset="-120"/>
+              </a:rPr>
+              <a:t>4</a:t>
+            </a:r>
+            <a:endParaRPr lang="en-US" sz="1600" dirty="0"/>
+          </a:p>
+        </p:txBody>
+      </p:sp>
+      <p:sp>
+        <p:nvSpPr>
+          <p:cNvPr id="37" name="Text 28"/>
+          <p:cNvSpPr txBox="1"/>
+          <p:nvPr/>
+        </p:nvSpPr>
+        <p:spPr>
+          <a:xfrm>
+            <a:off x="6766560" y="5321808"/>
+            <a:ext cx="4937760" cy="566928"/>
+          </a:xfrm>
+          <a:prstGeom prst="rect">
+            <a:avLst/>
+          </a:prstGeom>
+          <a:noFill/>
+          <a:ln/>
+        </p:spPr>
+        <p:txBody>
+          <a:bodyPr wrap="square" lIns="0" tIns="0" rIns="0" bIns="0" rtlCol="0" anchor="t"/>
+          <a:lstStyle/>
+          <a:p>
+            <a:pPr indent="0" marL="0">
+              <a:buNone/>
+            </a:pPr>
+            <a:r>
+              <a:rPr lang="en-US" sz="900" b="1" dirty="0">
+                <a:solidFill>
+                  <a:srgbClr val="FFFFFF"/>
+                </a:solidFill>
+                <a:latin typeface="Calibri" pitchFamily="34" charset="0"/>
+                <a:ea typeface="Calibri" pitchFamily="34" charset="-122"/>
+                <a:cs typeface="Calibri" pitchFamily="34" charset="-120"/>
+              </a:rPr>
+              <a:t>Correct &amp; Smooth, ICLR 2021 · APPNP, ICLR 2019</a:t>
+            </a:r>
+            <a:endParaRPr lang="en-US" sz="900" dirty="0"/>
+          </a:p>
+          <a:p>
+            <a:pPr indent="0" marL="0">
+              <a:buNone/>
+            </a:pPr>
+            <a:r>
+              <a:rPr lang="en-US" sz="900" dirty="0">
+                <a:solidFill>
+                  <a:srgbClr val="C9D6DA"/>
+                </a:solidFill>
+                <a:latin typeface="Calibri" pitchFamily="34" charset="0"/>
+                <a:ea typeface="Calibri" pitchFamily="34" charset="-122"/>
+                <a:cs typeface="Calibri" pitchFamily="34" charset="-120"/>
+              </a:rPr>
+              <a:t>Propagate a base classifier's output with (I − αP)⁻¹. That is where the Random Forest prior plugs in.</a:t>
+            </a:r>
+            <a:endParaRPr lang="en-US" sz="900" dirty="0"/>
+          </a:p>
+        </p:txBody>
+      </p:sp>
+      <p:sp>
+        <p:nvSpPr>
+          <p:cNvPr id="38" name="Shape 29"/>
+          <p:cNvSpPr/>
+          <p:nvPr/>
+        </p:nvSpPr>
+        <p:spPr>
+          <a:xfrm>
+            <a:off x="6400800" y="5925312"/>
+            <a:ext cx="256032" cy="256032"/>
+          </a:xfrm>
+          <a:prstGeom prst="ellipse">
+            <a:avLst/>
+          </a:prstGeom>
+          <a:solidFill>
+            <a:srgbClr val="02C39A"/>
+          </a:solidFill>
+          <a:ln w="12700">
+            <a:solidFill>
+              <a:srgbClr val="02C39A"/>
+            </a:solidFill>
+            <a:prstDash val="solid"/>
+          </a:ln>
+        </p:spPr>
+      </p:sp>
+      <p:sp>
+        <p:nvSpPr>
           <p:cNvPr id="39" name="Text 30"/>
           <p:cNvSpPr txBox="1"/>
           <p:nvPr/>
         </p:nvSpPr>
         <p:spPr>
           <a:xfrm>
-            <a:off x="6400800" y="5623560"/>
-            <a:ext cx="329184" cy="329184"/>
+            <a:off x="6400800" y="5925312"/>
+            <a:ext cx="256032" cy="256032"/>
           </a:xfrm>
           <a:prstGeom prst="rect">
             <a:avLst/>
@@ -16407,7 +16471,7 @@
                 <a:ea typeface="Calibri" pitchFamily="34" charset="-122"/>
                 <a:cs typeface="Calibri" pitchFamily="34" charset="-120"/>
               </a:rPr>
-              <a:t>✓</a:t>
+              <a:t>5</a:t>
             </a:r>
             <a:endParaRPr lang="en-US" sz="1600" dirty="0"/>
           </a:p>
@@ -16421,24 +16485,24 @@
         </p:nvSpPr>
         <p:spPr>
           <a:xfrm>
-            <a:off x="6858000" y="5605272"/>
-            <a:ext cx="4846320" cy="292608"/>
-          </a:xfrm>
-          <a:prstGeom prst="rect">
-            <a:avLst/>
-          </a:prstGeom>
-          <a:noFill/>
-          <a:ln/>
-        </p:spPr>
-        <p:txBody>
-          <a:bodyPr wrap="square" lIns="0" tIns="0" rIns="0" bIns="0" rtlCol="0" anchor="ctr"/>
+            <a:off x="6766560" y="5907024"/>
+            <a:ext cx="4937760" cy="566928"/>
+          </a:xfrm>
+          <a:prstGeom prst="rect">
+            <a:avLst/>
+          </a:prstGeom>
+          <a:noFill/>
+          <a:ln/>
+        </p:spPr>
+        <p:txBody>
+          <a:bodyPr wrap="square" lIns="0" tIns="0" rIns="0" bIns="0" rtlCol="0" anchor="t"/>
           <a:lstStyle/>
           <a:p>
             <a:pPr indent="0" marL="0">
               <a:buNone/>
             </a:pPr>
             <a:r>
-              <a:rPr lang="en-US" sz="1200" b="1" dirty="0">
+              <a:rPr lang="en-US" sz="900" b="1" dirty="0">
                 <a:solidFill>
                   <a:srgbClr val="FFFFFF"/>
                 </a:solidFill>
@@ -16446,38 +16510,16 @@
                 <a:ea typeface="Calibri" pitchFamily="34" charset="-122"/>
                 <a:cs typeface="Calibri" pitchFamily="34" charset="-120"/>
               </a:rPr>
-              <a:t>Explainable</a:t>
-            </a:r>
-            <a:endParaRPr lang="en-US" sz="1200" dirty="0"/>
-          </a:p>
-        </p:txBody>
-      </p:sp>
-      <p:sp>
-        <p:nvSpPr>
-          <p:cNvPr id="41" name="Text 32"/>
-          <p:cNvSpPr txBox="1"/>
-          <p:nvPr/>
-        </p:nvSpPr>
-        <p:spPr>
-          <a:xfrm>
-            <a:off x="6858000" y="5897880"/>
-            <a:ext cx="4846320" cy="502920"/>
-          </a:xfrm>
-          <a:prstGeom prst="rect">
-            <a:avLst/>
-          </a:prstGeom>
-          <a:noFill/>
-          <a:ln/>
-        </p:spPr>
-        <p:txBody>
-          <a:bodyPr wrap="square" lIns="0" tIns="0" rIns="0" bIns="0" rtlCol="0" anchor="t"/>
-          <a:lstStyle/>
+              <a:t>Alvisi et al., SoK, IEEE S&amp;P 2013</a:t>
+            </a:r>
+            <a:endParaRPr lang="en-US" sz="900" dirty="0"/>
+          </a:p>
           <a:p>
             <a:pPr indent="0" marL="0">
               <a:buNone/>
             </a:pPr>
             <a:r>
-              <a:rPr lang="en-US" sz="1000" dirty="0">
+              <a:rPr lang="en-US" sz="900" dirty="0">
                 <a:solidFill>
                   <a:srgbClr val="C9D6DA"/>
                 </a:solidFill>
@@ -16485,9 +16527,9 @@
                 <a:ea typeface="Calibri" pitchFamily="34" charset="-122"/>
                 <a:cs typeface="Calibri" pitchFamily="34" charset="-120"/>
               </a:rPr>
-              <a:t>r* is linear in q: every score splits exactly into prior + per-relation + per-neighbour terms.</a:t>
-            </a:r>
-            <a:endParaRPr lang="en-US" sz="1000" dirty="0"/>
+              <a:t>Sybil defence is ranking by seeded propagation, and needs defence in depth: structure plus a behavioural prior.</a:t>
+            </a:r>
+            <a:endParaRPr lang="en-US" sz="900" dirty="0"/>
           </a:p>
         </p:txBody>
       </p:sp>

</xml_diff>